<commit_message>
Add new theme and style files for PowerPoint presentation
- Created tableStyles.xml to define table styles with a default style ID.
- Added theme1.xml to introduce a new custom theme named "Office 主题​​" with a comprehensive color scheme, font scheme, and formatting styles.
- Introduced viewProps.xml to set default view properties for the presentation, including slide and notes view settings.
- Established taskpanes.xml and its relationships to define two web extensions for task panes in the presentation.
- Created webextension1.xml and webextension2.xml to define properties and references for the respective web extensions.
</commit_message>
<xml_diff>
--- a/Drafts/Design Draft.pptx
+++ b/Drafts/Design Draft.pptx
@@ -104,6 +104,11 @@
       </a:defRPr>
     </a:lvl9pPr>
   </p:defaultTextStyle>
+  <p:extLst>
+    <p:ext uri="{EFAFB233-063F-42B5-8137-9DF3F51BA10A}">
+      <p15:sldGuideLst xmlns:p15="http://schemas.microsoft.com/office/powerpoint/2012/main"/>
+    </p:ext>
+  </p:extLst>
 </p:presentation>
 </file>
 
@@ -239,7 +244,7 @@
             <a:fld id="{8256C2ED-54A4-480D-B5C8-65C0D62359B9}" type="datetime2">
               <a:rPr lang="en-US" smtClean="0"/>
               <a:pPr/>
-              <a:t>Wednesday, April 22, 2026</a:t>
+              <a:t>Thursday, April 23, 2026</a:t>
             </a:fld>
             <a:endParaRPr lang="en-US" dirty="0"/>
           </a:p>
@@ -416,7 +421,7 @@
             <a:fld id="{8256C2ED-54A4-480D-B5C8-65C0D62359B9}" type="datetime2">
               <a:rPr lang="en-US" smtClean="0"/>
               <a:pPr/>
-              <a:t>Wednesday, April 22, 2026</a:t>
+              <a:t>Thursday, April 23, 2026</a:t>
             </a:fld>
             <a:endParaRPr lang="en-US" dirty="0"/>
           </a:p>
@@ -603,7 +608,7 @@
             <a:fld id="{8256C2ED-54A4-480D-B5C8-65C0D62359B9}" type="datetime2">
               <a:rPr lang="en-US" smtClean="0"/>
               <a:pPr/>
-              <a:t>Wednesday, April 22, 2026</a:t>
+              <a:t>Thursday, April 23, 2026</a:t>
             </a:fld>
             <a:endParaRPr lang="en-US" dirty="0"/>
           </a:p>
@@ -780,7 +785,7 @@
             <a:fld id="{8256C2ED-54A4-480D-B5C8-65C0D62359B9}" type="datetime2">
               <a:rPr lang="en-US" smtClean="0"/>
               <a:pPr/>
-              <a:t>Wednesday, April 22, 2026</a:t>
+              <a:t>Thursday, April 23, 2026</a:t>
             </a:fld>
             <a:endParaRPr lang="en-US" dirty="0"/>
           </a:p>
@@ -1033,7 +1038,7 @@
             <a:fld id="{8256C2ED-54A4-480D-B5C8-65C0D62359B9}" type="datetime2">
               <a:rPr lang="en-US" smtClean="0"/>
               <a:pPr/>
-              <a:t>Wednesday, April 22, 2026</a:t>
+              <a:t>Thursday, April 23, 2026</a:t>
             </a:fld>
             <a:endParaRPr lang="en-US" dirty="0"/>
           </a:p>
@@ -1272,7 +1277,7 @@
             <a:fld id="{8256C2ED-54A4-480D-B5C8-65C0D62359B9}" type="datetime2">
               <a:rPr lang="en-US" smtClean="0"/>
               <a:pPr/>
-              <a:t>Wednesday, April 22, 2026</a:t>
+              <a:t>Thursday, April 23, 2026</a:t>
             </a:fld>
             <a:endParaRPr lang="en-US" dirty="0"/>
           </a:p>
@@ -1646,7 +1651,7 @@
             <a:fld id="{8256C2ED-54A4-480D-B5C8-65C0D62359B9}" type="datetime2">
               <a:rPr lang="en-US" smtClean="0"/>
               <a:pPr/>
-              <a:t>Wednesday, April 22, 2026</a:t>
+              <a:t>Thursday, April 23, 2026</a:t>
             </a:fld>
             <a:endParaRPr lang="en-US" dirty="0"/>
           </a:p>
@@ -1771,7 +1776,7 @@
             <a:fld id="{8256C2ED-54A4-480D-B5C8-65C0D62359B9}" type="datetime2">
               <a:rPr lang="en-US" smtClean="0"/>
               <a:pPr/>
-              <a:t>Wednesday, April 22, 2026</a:t>
+              <a:t>Thursday, April 23, 2026</a:t>
             </a:fld>
             <a:endParaRPr lang="en-US" dirty="0"/>
           </a:p>
@@ -1873,7 +1878,7 @@
             <a:fld id="{8256C2ED-54A4-480D-B5C8-65C0D62359B9}" type="datetime2">
               <a:rPr lang="en-US" smtClean="0"/>
               <a:pPr/>
-              <a:t>Wednesday, April 22, 2026</a:t>
+              <a:t>Thursday, April 23, 2026</a:t>
             </a:fld>
             <a:endParaRPr lang="en-US" dirty="0"/>
           </a:p>
@@ -2157,7 +2162,7 @@
             <a:fld id="{8256C2ED-54A4-480D-B5C8-65C0D62359B9}" type="datetime2">
               <a:rPr lang="en-US" smtClean="0"/>
               <a:pPr/>
-              <a:t>Wednesday, April 22, 2026</a:t>
+              <a:t>Thursday, April 23, 2026</a:t>
             </a:fld>
             <a:endParaRPr lang="en-US" dirty="0"/>
           </a:p>
@@ -2421,7 +2426,7 @@
             <a:fld id="{8256C2ED-54A4-480D-B5C8-65C0D62359B9}" type="datetime2">
               <a:rPr lang="en-US" smtClean="0"/>
               <a:pPr/>
-              <a:t>Wednesday, April 22, 2026</a:t>
+              <a:t>Thursday, April 23, 2026</a:t>
             </a:fld>
             <a:endParaRPr lang="en-US" dirty="0"/>
           </a:p>
@@ -2641,7 +2646,7 @@
             <a:fld id="{8256C2ED-54A4-480D-B5C8-65C0D62359B9}" type="datetime2">
               <a:rPr lang="en-US" smtClean="0"/>
               <a:pPr/>
-              <a:t>Wednesday, April 22, 2026</a:t>
+              <a:t>Thursday, April 23, 2026</a:t>
             </a:fld>
             <a:endParaRPr lang="en-US" dirty="0"/>
           </a:p>
@@ -3757,8 +3762,8 @@
         </p:nvSpPr>
         <p:spPr>
           <a:xfrm>
-            <a:off x="345486" y="4332458"/>
-            <a:ext cx="1435188" cy="282437"/>
+            <a:off x="345485" y="4332458"/>
+            <a:ext cx="4093811" cy="282437"/>
           </a:xfrm>
           <a:prstGeom prst="roundRect">
             <a:avLst>
@@ -4627,4 +4632,39 @@
     </a:ext>
   </a:extLst>
 </a:theme>
+</file>
+
+<file path=ppt/webextensions/taskpanes.xml><?xml version="1.0" encoding="utf-8"?>
+<wetp:taskpanes xmlns:wetp="http://schemas.microsoft.com/office/webextensions/taskpanes/2010/11">
+  <wetp:taskpane dockstate="right" visibility="0" width="350" row="0">
+    <wetp:webextensionref xmlns:r="http://schemas.openxmlformats.org/officeDocument/2006/relationships" r:id="rId1"/>
+  </wetp:taskpane>
+  <wetp:taskpane dockstate="right" visibility="0" width="350" row="0">
+    <wetp:webextensionref xmlns:r="http://schemas.openxmlformats.org/officeDocument/2006/relationships" r:id="rId2"/>
+  </wetp:taskpane>
+</wetp:taskpanes>
+</file>
+
+<file path=ppt/webextensions/webextension1.xml><?xml version="1.0" encoding="utf-8"?>
+<we:webextension xmlns:we="http://schemas.microsoft.com/office/webextensions/webextension/2010/11" id="{91DE601F-B7A8-924F-B134-54C42D7F4152}">
+  <we:reference id="wa200005566" version="3.0.0.2" store="zh-CN" storeType="OMEX"/>
+  <we:alternateReferences>
+    <we:reference id="WA200005566" version="3.0.0.2" store="" storeType="OMEX"/>
+  </we:alternateReferences>
+  <we:properties/>
+  <we:bindings/>
+  <we:snapshot xmlns:r="http://schemas.openxmlformats.org/officeDocument/2006/relationships"/>
+</we:webextension>
+</file>
+
+<file path=ppt/webextensions/webextension2.xml><?xml version="1.0" encoding="utf-8"?>
+<we:webextension xmlns:we="http://schemas.microsoft.com/office/webextensions/webextension/2010/11" id="{D944C907-A97A-BB44-B28C-C528CE1366E1}">
+  <we:reference id="wa104381909" version="3.14.0.0" store="en-US" storeType="OMEX"/>
+  <we:alternateReferences>
+    <we:reference id="WA104381909" version="3.14.0.0" store="" storeType="OMEX"/>
+  </we:alternateReferences>
+  <we:properties/>
+  <we:bindings/>
+  <we:snapshot xmlns:r="http://schemas.openxmlformats.org/officeDocument/2006/relationships"/>
+</we:webextension>
 </file>
</xml_diff>

<commit_message>
Remove unused XML files and web extensions from the presentation draft; add VSCode settings for PPTX files.
</commit_message>
<xml_diff>
--- a/Drafts/Design Draft.pptx
+++ b/Drafts/Design Draft.pptx
@@ -1,11 +1,12 @@
 
 <file path=ppt/presentation.xml><?xml version="1.0" encoding="utf-8"?>
-<p:presentation xmlns:a="http://schemas.openxmlformats.org/drawingml/2006/main" xmlns:r="http://schemas.openxmlformats.org/officeDocument/2006/relationships" xmlns:p="http://schemas.openxmlformats.org/presentationml/2006/main" saveSubsetFonts="1" autoCompressPictures="0">
+<p:presentation xmlns:p15="http://schemas.microsoft.com/office/powerpoint/2012/main" xmlns:a="http://schemas.openxmlformats.org/drawingml/2006/main" xmlns:r="http://schemas.openxmlformats.org/officeDocument/2006/relationships" xmlns:p="http://schemas.openxmlformats.org/presentationml/2006/main" saveSubsetFonts="1" autoCompressPictures="0">
   <p:sldMasterIdLst>
     <p:sldMasterId id="2147483786" r:id="rId1"/>
   </p:sldMasterIdLst>
   <p:sldIdLst>
     <p:sldId id="256" r:id="rId2"/>
+    <p:sldId id="257" r:id="R0660a2a2297a4cf7"/>
   </p:sldIdLst>
   <p:sldSz cx="12192000" cy="6858000"/>
   <p:notesSz cx="6858000" cy="9144000"/>
@@ -113,7 +114,7 @@
 </file>
 
 <file path=ppt/slideLayouts/slideLayout1.xml><?xml version="1.0" encoding="utf-8"?>
-<p:sldLayout xmlns:a="http://schemas.openxmlformats.org/drawingml/2006/main" xmlns:r="http://schemas.openxmlformats.org/officeDocument/2006/relationships" xmlns:p="http://schemas.openxmlformats.org/presentationml/2006/main" type="title" preserve="1">
+<p:sldLayout xmlns:p14="http://schemas.microsoft.com/office/powerpoint/2010/main" xmlns:a="http://schemas.openxmlformats.org/drawingml/2006/main" xmlns:r="http://schemas.openxmlformats.org/officeDocument/2006/relationships" xmlns:p="http://schemas.openxmlformats.org/presentationml/2006/main" type="title" preserve="1">
   <p:cSld name="标题幻灯片">
     <p:spTree>
       <p:nvGrpSpPr>
@@ -1946,7 +1947,7 @@
 </file>
 
 <file path=ppt/slideLayouts/slideLayout8.xml><?xml version="1.0" encoding="utf-8"?>
-<p:sldLayout xmlns:a="http://schemas.openxmlformats.org/drawingml/2006/main" xmlns:r="http://schemas.openxmlformats.org/officeDocument/2006/relationships" xmlns:p="http://schemas.openxmlformats.org/presentationml/2006/main" type="objTx" preserve="1">
+<p:sldLayout xmlns:p14="http://schemas.microsoft.com/office/powerpoint/2010/main" xmlns:a="http://schemas.openxmlformats.org/drawingml/2006/main" xmlns:r="http://schemas.openxmlformats.org/officeDocument/2006/relationships" xmlns:p="http://schemas.openxmlformats.org/presentationml/2006/main" type="objTx" preserve="1">
   <p:cSld name="内容与标题">
     <p:spTree>
       <p:nvGrpSpPr>
@@ -2494,7 +2495,7 @@
 </file>
 
 <file path=ppt/slideMasters/slideMaster1.xml><?xml version="1.0" encoding="utf-8"?>
-<p:sldMaster xmlns:a="http://schemas.openxmlformats.org/drawingml/2006/main" xmlns:r="http://schemas.openxmlformats.org/officeDocument/2006/relationships" xmlns:p="http://schemas.openxmlformats.org/presentationml/2006/main">
+<p:sldMaster xmlns:p14="http://schemas.microsoft.com/office/powerpoint/2010/main" xmlns:a="http://schemas.openxmlformats.org/drawingml/2006/main" xmlns:r="http://schemas.openxmlformats.org/officeDocument/2006/relationships" xmlns:p="http://schemas.openxmlformats.org/presentationml/2006/main">
   <p:cSld>
     <p:bg>
       <p:bgRef idx="1001">
@@ -3041,7 +3042,7 @@
 </file>
 
 <file path=ppt/slides/slide1.xml><?xml version="1.0" encoding="utf-8"?>
-<p:sld xmlns:a="http://schemas.openxmlformats.org/drawingml/2006/main" xmlns:r="http://schemas.openxmlformats.org/officeDocument/2006/relationships" xmlns:p="http://schemas.openxmlformats.org/presentationml/2006/main">
+<p:sld xmlns:a16="http://schemas.microsoft.com/office/drawing/2014/main" xmlns:asvg="http://schemas.microsoft.com/office/drawing/2016/SVG/main" xmlns:p14="http://schemas.microsoft.com/office/powerpoint/2010/main" xmlns:a="http://schemas.openxmlformats.org/drawingml/2006/main" xmlns:r="http://schemas.openxmlformats.org/officeDocument/2006/relationships" xmlns:p="http://schemas.openxmlformats.org/presentationml/2006/main">
   <p:cSld>
     <p:bg>
       <p:bgPr>
@@ -3194,7 +3195,7 @@
                 <a:ea typeface="Palatino" pitchFamily="2" charset="0"/>
                 <a:cs typeface="Mongolian Baiti" panose="03000500000000000000" pitchFamily="66" charset="0"/>
               </a:rPr>
-              <a:t>Exclusive Summary: grow Fruit Co. by store expansion with supply chain optimization, product diversification, and purchasing experience management</a:t>
+              <a:t>Executive Summary: Drive Fruit Co. growth through store expansion, supply chain optimization, product diversification, and improved purchasing experience</a:t>
             </a:r>
           </a:p>
         </p:txBody>
@@ -3311,7 +3312,7 @@
                   <a:schemeClr val="tx1"/>
                 </a:solidFill>
               </a:rPr>
-              <a:t>Retrofit merchant projects to stabilize cash flows while expanding EE’s global BESS network in high-return markets. Convert German standalone tolling projects to boost equity growth. Optimized portfolio equity allocations were achieved using </a:t>
+              <a:t>Restructure merchant projects to stabilize cash flows while expanding EE’s global BESS network in high-return markets. Convert German standalone tolling projects to drive equity growth. Portfolio equity allocations optimized via </a:t>
             </a:r>
             <a:r>
               <a:rPr kumimoji="1" lang="en-US" altLang="zh-CN" sz="1400" b="1" dirty="0">
@@ -3488,7 +3489,7 @@
             </a:pPr>
             <a:r>
               <a:rPr kumimoji="1" lang="en-US" altLang="zh-CN" sz="1400" dirty="0"/>
-              <a:t>Use short development cycles to adapt swiftly to rapidly evolving battery technology</a:t>
+              <a:t>Adopt short development cycles to keep pace with rapidly evolving battery tech</a:t>
             </a:r>
           </a:p>
           <a:p>
@@ -3498,7 +3499,7 @@
             </a:pPr>
             <a:r>
               <a:rPr kumimoji="1" lang="en-US" altLang="zh-CN" sz="1400" dirty="0"/>
-              <a:t>Reduce costs with 30% of CAPEX grants</a:t>
+              <a:t>Slash costs with 30% CAPEX grants</a:t>
             </a:r>
             <a:endParaRPr kumimoji="1" lang="zh-CN" altLang="en-US" sz="1400" dirty="0"/>
           </a:p>
@@ -3654,7 +3655,7 @@
                   <a:schemeClr val="tx1"/>
                 </a:solidFill>
               </a:rPr>
-              <a:t>Close the value gap between high-output and low-revenue markets through full-chain control</a:t>
+              <a:t>Bridge the value gap between high-output and low-revenue markets via full-chain control</a:t>
             </a:r>
             <a:endParaRPr kumimoji="1" lang="en-US" altLang="zh-CN" sz="1400" b="1" dirty="0">
               <a:solidFill>
@@ -3735,7 +3736,7 @@
                   </a:schemeClr>
                 </a:solidFill>
               </a:rPr>
-              <a:t>Source: expert call, lit research, analysis</a:t>
+              <a:t>Source: expert interviews, literature review, analysis</a:t>
             </a:r>
             <a:endParaRPr kumimoji="1" lang="zh-CN" altLang="en-US" sz="1400" dirty="0">
               <a:solidFill>
@@ -4022,7 +4023,7 @@
                   <a:schemeClr val="tx1"/>
                 </a:solidFill>
               </a:rPr>
-              <a:t>Genki Forest is suggested to raise ex-factory price by CN¥0.25–0.30 per bottle</a:t>
+              <a:t>Recommend raising ex-factory prices by CN¥0.25–0.30 per bottle for Genki Forest</a:t>
             </a:r>
           </a:p>
           <a:p>
@@ -4036,7 +4037,7 @@
                   <a:schemeClr val="tx1"/>
                 </a:solidFill>
               </a:rPr>
-              <a:t>Terminal price could raise CN¥0.30–0.50 per bottle</a:t>
+              <a:t>Retail prices could rise CN¥0.30–0.50 per bottle</a:t>
             </a:r>
           </a:p>
           <a:p>
@@ -4050,7 +4051,7 @@
                   <a:schemeClr val="tx1"/>
                 </a:solidFill>
               </a:rPr>
-              <a:t>Potential risk and mitigation exist in implementation</a:t>
+              <a:t>Implementation risks and mitigations identified</a:t>
             </a:r>
           </a:p>
         </p:txBody>
@@ -4085,7 +4086,7 @@
           <a:p>
             <a:r>
               <a:rPr kumimoji="1" lang="en-US" altLang="zh-CN" sz="1600" b="1" dirty="0"/>
-              <a:t>Original customer base has relatively lower price sensitivity</a:t>
+              <a:t>Existing customers show relatively lower price sensitivity</a:t>
             </a:r>
             <a:endParaRPr kumimoji="1" lang="zh-CN" altLang="en-US" sz="1600" b="1" dirty="0"/>
           </a:p>
@@ -4262,7 +4263,7 @@
                   <a:schemeClr val="tx1"/>
                 </a:solidFill>
               </a:rPr>
-              <a:t>Close the value gap between high-output and low-revenue markets through full-chain control</a:t>
+              <a:t>Bridge the value gap between high-output and low-revenue markets via full-chain control</a:t>
             </a:r>
             <a:endParaRPr kumimoji="1" lang="en-US" altLang="zh-CN" sz="1400" b="1" dirty="0">
               <a:solidFill>
@@ -4319,8 +4320,867 @@
 </p:sld>
 </file>
 
+<file path=ppt/slides/slide2.xml><?xml version="1.0" encoding="utf-8"?>
+<p:sld xmlns:a="http://schemas.openxmlformats.org/drawingml/2006/main" xmlns:a16="http://schemas.microsoft.com/office/drawing/2014/main" xmlns:asvg="http://schemas.microsoft.com/office/drawing/2016/SVG/main" xmlns:r="http://schemas.openxmlformats.org/officeDocument/2006/relationships" xmlns:p="http://schemas.openxmlformats.org/presentationml/2006/main">
+  <p:cSld>
+    <p:spTree>
+      <p:nvGrpSpPr>
+        <p:cNvPr id="1" name=""/>
+        <p:cNvGrpSpPr/>
+        <p:nvPr/>
+      </p:nvGrpSpPr>
+      <p:grpSpPr/>
+      <p:sp>
+        <p:nvSpPr>
+          <p:cNvPr id="2" name="Title"/>
+          <p:cNvSpPr/>
+          <p:nvPr>
+            <p:ph type="title"/>
+          </p:nvPr>
+        </p:nvSpPr>
+        <p:spPr>
+          <a:xfrm xmlns:a="http://schemas.openxmlformats.org/drawingml/2006/main">
+            <a:off x="838200" y="365125"/>
+            <a:ext cx="10515600" cy="1325563"/>
+          </a:xfrm>
+        </p:spPr>
+        <p:txBody>
+          <a:bodyPr xmlns:a="http://schemas.openxmlformats.org/drawingml/2006/main"/>
+          <a:lstStyle xmlns:a="http://schemas.openxmlformats.org/drawingml/2006/main"/>
+          <a:p xmlns:a="http://schemas.openxmlformats.org/drawingml/2006/main">
+            <a:r>
+              <a:rPr lang="en-US"/>
+              <a:t>New Slide</a:t>
+            </a:r>
+          </a:p>
+        </p:txBody>
+      </p:sp>
+      <p:pic>
+        <p:nvPicPr>
+          <p:cNvPr id="10000" name="图形 60">
+            <a:extLst xmlns:a="http://schemas.openxmlformats.org/drawingml/2006/main">
+              <a:ext uri="{FF2B5EF4-FFF2-40B4-BE49-F238E27FC236}">
+                <a16:creationId xmlns:a16="http://schemas.microsoft.com/office/drawing/2014/main" id="{CD67FE52-B21D-D467-FA8C-18471F8E339A}"/>
+              </a:ext>
+            </a:extLst>
+          </p:cNvPr>
+          <p:cNvPicPr>
+            <a:picLocks xmlns:a="http://schemas.openxmlformats.org/drawingml/2006/main" noChangeAspect="1"/>
+          </p:cNvPicPr>
+          <p:nvPr/>
+        </p:nvPicPr>
+        <p:blipFill>
+          <a:blip xmlns:a="http://schemas.openxmlformats.org/drawingml/2006/main">
+            <a:extLst>
+              <a:ext uri="{96DAC541-7B7A-43D3-8B79-37D633B846F1}">
+                <asvg:svgBlip xmlns:asvg="http://schemas.microsoft.com/office/drawing/2016/SVG/main" xmlns:r="http://schemas.openxmlformats.org/officeDocument/2006/relationships" r:embed="R4708a209b2ba47fa"/>
+              </a:ext>
+            </a:extLst>
+          </a:blip>
+          <a:srcRect xmlns:a="http://schemas.openxmlformats.org/drawingml/2006/main"/>
+          <a:stretch xmlns:a="http://schemas.openxmlformats.org/drawingml/2006/main"/>
+        </p:blipFill>
+        <p:spPr>
+          <a:xfrm xmlns:a="http://schemas.openxmlformats.org/drawingml/2006/main">
+            <a:off x="10888462" y="6534398"/>
+            <a:ext cx="762838" cy="203586"/>
+          </a:xfrm>
+          <a:prstGeom xmlns:a="http://schemas.openxmlformats.org/drawingml/2006/main" prst="rect">
+            <a:avLst/>
+          </a:prstGeom>
+        </p:spPr>
+      </p:pic>
+      <p:cxnSp>
+        <p:nvCxnSpPr>
+          <p:cNvPr id="10001" name="直线连接符 37">
+            <a:extLst xmlns:a="http://schemas.openxmlformats.org/drawingml/2006/main">
+              <a:ext uri="{FF2B5EF4-FFF2-40B4-BE49-F238E27FC236}">
+                <a16:creationId xmlns:a16="http://schemas.microsoft.com/office/drawing/2014/main" id="{02F3A8E7-106F-591D-F7DE-2793A8B3EA7F}"/>
+              </a:ext>
+            </a:extLst>
+          </p:cNvPr>
+          <p:cNvCxnSpPr/>
+          <p:nvPr/>
+        </p:nvCxnSpPr>
+        <p:spPr>
+          <a:xfrm xmlns:a="http://schemas.openxmlformats.org/drawingml/2006/main" flipV="1">
+            <a:off x="6153443" y="2759531"/>
+            <a:ext cx="0" cy="265626"/>
+          </a:xfrm>
+          <a:prstGeom xmlns:a="http://schemas.openxmlformats.org/drawingml/2006/main" prst="line">
+            <a:avLst/>
+          </a:prstGeom>
+          <a:ln xmlns:a="http://schemas.openxmlformats.org/drawingml/2006/main" w="31750" cap="sq">
+            <a:solidFill>
+              <a:schemeClr val="tx2"/>
+            </a:solidFill>
+            <a:miter lim="800000"/>
+            <a:tailEnd w="sm" len="sm"/>
+          </a:ln>
+        </p:spPr>
+        <p:style>
+          <a:lnRef xmlns:a="http://schemas.openxmlformats.org/drawingml/2006/main" idx="2">
+            <a:schemeClr val="accent1"/>
+          </a:lnRef>
+          <a:fillRef xmlns:a="http://schemas.openxmlformats.org/drawingml/2006/main" idx="0">
+            <a:schemeClr val="accent1"/>
+          </a:fillRef>
+          <a:effectRef xmlns:a="http://schemas.openxmlformats.org/drawingml/2006/main" idx="1">
+            <a:schemeClr val="accent1"/>
+          </a:effectRef>
+          <a:fontRef xmlns:a="http://schemas.openxmlformats.org/drawingml/2006/main" idx="minor">
+            <a:schemeClr val="tx1"/>
+          </a:fontRef>
+        </p:style>
+      </p:cxnSp>
+      <p:cxnSp>
+        <p:nvCxnSpPr>
+          <p:cNvPr id="10002" name="直线连接符 39">
+            <a:extLst xmlns:a="http://schemas.openxmlformats.org/drawingml/2006/main">
+              <a:ext uri="{FF2B5EF4-FFF2-40B4-BE49-F238E27FC236}">
+                <a16:creationId xmlns:a16="http://schemas.microsoft.com/office/drawing/2014/main" id="{A2AA58F1-8C5F-12B1-E566-EF8BAB04F2C1}"/>
+              </a:ext>
+            </a:extLst>
+          </p:cNvPr>
+          <p:cNvCxnSpPr/>
+          <p:nvPr/>
+        </p:nvCxnSpPr>
+        <p:spPr>
+          <a:xfrm xmlns:a="http://schemas.openxmlformats.org/drawingml/2006/main">
+            <a:off x="6153443" y="2759531"/>
+            <a:ext cx="1140643" cy="0"/>
+          </a:xfrm>
+          <a:prstGeom xmlns:a="http://schemas.openxmlformats.org/drawingml/2006/main" prst="line">
+            <a:avLst/>
+          </a:prstGeom>
+          <a:ln xmlns:a="http://schemas.openxmlformats.org/drawingml/2006/main" w="31750" cap="sq">
+            <a:solidFill>
+              <a:schemeClr val="tx2"/>
+            </a:solidFill>
+            <a:miter lim="800000"/>
+            <a:tailEnd type="oval" w="sm" len="sm"/>
+          </a:ln>
+        </p:spPr>
+        <p:style>
+          <a:lnRef xmlns:a="http://schemas.openxmlformats.org/drawingml/2006/main" idx="2">
+            <a:schemeClr val="accent1"/>
+          </a:lnRef>
+          <a:fillRef xmlns:a="http://schemas.openxmlformats.org/drawingml/2006/main" idx="0">
+            <a:schemeClr val="accent1"/>
+          </a:fillRef>
+          <a:effectRef xmlns:a="http://schemas.openxmlformats.org/drawingml/2006/main" idx="1">
+            <a:schemeClr val="accent1"/>
+          </a:effectRef>
+          <a:fontRef xmlns:a="http://schemas.openxmlformats.org/drawingml/2006/main" idx="minor">
+            <a:schemeClr val="tx1"/>
+          </a:fontRef>
+        </p:style>
+      </p:cxnSp>
+      <p:cxnSp>
+        <p:nvCxnSpPr>
+          <p:cNvPr id="10003" name="直线连接符 57">
+            <a:extLst xmlns:a="http://schemas.openxmlformats.org/drawingml/2006/main">
+              <a:ext uri="{FF2B5EF4-FFF2-40B4-BE49-F238E27FC236}">
+                <a16:creationId xmlns:a16="http://schemas.microsoft.com/office/drawing/2014/main" id="{4CC9D08D-A330-065D-B982-D792D996573E}"/>
+              </a:ext>
+            </a:extLst>
+          </p:cNvPr>
+          <p:cNvCxnSpPr>
+            <a:cxnSpLocks xmlns:a="http://schemas.openxmlformats.org/drawingml/2006/main"/>
+          </p:cNvCxnSpPr>
+          <p:nvPr/>
+        </p:nvCxnSpPr>
+        <p:spPr>
+          <a:xfrm xmlns:a="http://schemas.openxmlformats.org/drawingml/2006/main">
+            <a:off x="345486" y="872723"/>
+            <a:ext cx="11501023" cy="0"/>
+          </a:xfrm>
+          <a:prstGeom xmlns:a="http://schemas.openxmlformats.org/drawingml/2006/main" prst="line">
+            <a:avLst/>
+          </a:prstGeom>
+          <a:ln xmlns:a="http://schemas.openxmlformats.org/drawingml/2006/main">
+            <a:solidFill>
+              <a:schemeClr val="tx2"/>
+            </a:solidFill>
+          </a:ln>
+        </p:spPr>
+        <p:style>
+          <a:lnRef xmlns:a="http://schemas.openxmlformats.org/drawingml/2006/main" idx="2">
+            <a:schemeClr val="accent1"/>
+          </a:lnRef>
+          <a:fillRef xmlns:a="http://schemas.openxmlformats.org/drawingml/2006/main" idx="0">
+            <a:schemeClr val="accent1"/>
+          </a:fillRef>
+          <a:effectRef xmlns:a="http://schemas.openxmlformats.org/drawingml/2006/main" idx="1">
+            <a:schemeClr val="accent1"/>
+          </a:effectRef>
+          <a:fontRef xmlns:a="http://schemas.openxmlformats.org/drawingml/2006/main" idx="minor">
+            <a:schemeClr val="tx1"/>
+          </a:fontRef>
+        </p:style>
+      </p:cxnSp>
+      <p:cxnSp>
+        <p:nvCxnSpPr>
+          <p:cNvPr id="10004" name="直线连接符 78">
+            <a:extLst xmlns:a="http://schemas.openxmlformats.org/drawingml/2006/main">
+              <a:ext uri="{FF2B5EF4-FFF2-40B4-BE49-F238E27FC236}">
+                <a16:creationId xmlns:a16="http://schemas.microsoft.com/office/drawing/2014/main" id="{7B9A5B20-BEFA-0ADD-2D2A-70ED7D6302C9}"/>
+              </a:ext>
+            </a:extLst>
+          </p:cNvPr>
+          <p:cNvCxnSpPr>
+            <a:cxnSpLocks xmlns:a="http://schemas.openxmlformats.org/drawingml/2006/main"/>
+          </p:cNvCxnSpPr>
+          <p:nvPr/>
+        </p:nvCxnSpPr>
+        <p:spPr>
+          <a:xfrm xmlns:a="http://schemas.openxmlformats.org/drawingml/2006/main">
+            <a:off x="345486" y="2444416"/>
+            <a:ext cx="4093812" cy="0"/>
+          </a:xfrm>
+          <a:prstGeom xmlns:a="http://schemas.openxmlformats.org/drawingml/2006/main" prst="line">
+            <a:avLst/>
+          </a:prstGeom>
+          <a:ln xmlns:a="http://schemas.openxmlformats.org/drawingml/2006/main">
+            <a:solidFill>
+              <a:schemeClr val="tx2"/>
+            </a:solidFill>
+          </a:ln>
+        </p:spPr>
+        <p:style>
+          <a:lnRef xmlns:a="http://schemas.openxmlformats.org/drawingml/2006/main" idx="2">
+            <a:schemeClr val="accent1"/>
+          </a:lnRef>
+          <a:fillRef xmlns:a="http://schemas.openxmlformats.org/drawingml/2006/main" idx="0">
+            <a:schemeClr val="accent1"/>
+          </a:fillRef>
+          <a:effectRef xmlns:a="http://schemas.openxmlformats.org/drawingml/2006/main" idx="1">
+            <a:schemeClr val="accent1"/>
+          </a:effectRef>
+          <a:fontRef xmlns:a="http://schemas.openxmlformats.org/drawingml/2006/main" idx="minor">
+            <a:schemeClr val="tx1"/>
+          </a:fontRef>
+        </p:style>
+      </p:cxnSp>
+      <p:cxnSp>
+        <p:nvCxnSpPr>
+          <p:cNvPr id="10005" name="直线连接符 87">
+            <a:extLst xmlns:a="http://schemas.openxmlformats.org/drawingml/2006/main">
+              <a:ext uri="{FF2B5EF4-FFF2-40B4-BE49-F238E27FC236}">
+                <a16:creationId xmlns:a16="http://schemas.microsoft.com/office/drawing/2014/main" id="{90C26054-AA2D-AD8B-BC84-E6DEC9B17FA7}"/>
+              </a:ext>
+            </a:extLst>
+          </p:cNvPr>
+          <p:cNvCxnSpPr>
+            <a:cxnSpLocks xmlns:a="http://schemas.openxmlformats.org/drawingml/2006/main"/>
+          </p:cNvCxnSpPr>
+          <p:nvPr/>
+        </p:nvCxnSpPr>
+        <p:spPr>
+          <a:xfrm xmlns:a="http://schemas.openxmlformats.org/drawingml/2006/main">
+            <a:off x="5139910" y="4756113"/>
+            <a:ext cx="6708559" cy="0"/>
+          </a:xfrm>
+          <a:prstGeom xmlns:a="http://schemas.openxmlformats.org/drawingml/2006/main" prst="line">
+            <a:avLst/>
+          </a:prstGeom>
+          <a:ln xmlns:a="http://schemas.openxmlformats.org/drawingml/2006/main">
+            <a:solidFill>
+              <a:schemeClr val="tx2"/>
+            </a:solidFill>
+          </a:ln>
+        </p:spPr>
+        <p:style>
+          <a:lnRef xmlns:a="http://schemas.openxmlformats.org/drawingml/2006/main" idx="2">
+            <a:schemeClr val="accent1"/>
+          </a:lnRef>
+          <a:fillRef xmlns:a="http://schemas.openxmlformats.org/drawingml/2006/main" idx="0">
+            <a:schemeClr val="accent1"/>
+          </a:fillRef>
+          <a:effectRef xmlns:a="http://schemas.openxmlformats.org/drawingml/2006/main" idx="1">
+            <a:schemeClr val="accent1"/>
+          </a:effectRef>
+          <a:fontRef xmlns:a="http://schemas.openxmlformats.org/drawingml/2006/main" idx="minor">
+            <a:schemeClr val="tx1"/>
+          </a:fontRef>
+        </p:style>
+      </p:cxnSp>
+      <p:sp>
+        <p:nvSpPr>
+          <p:cNvPr id="10006" name="矩形 91">
+            <a:extLst xmlns:a="http://schemas.openxmlformats.org/drawingml/2006/main">
+              <a:ext uri="{FF2B5EF4-FFF2-40B4-BE49-F238E27FC236}">
+                <a16:creationId xmlns:a16="http://schemas.microsoft.com/office/drawing/2014/main" id="{8867E2AE-94E7-1A73-6E90-690A565127A1}"/>
+              </a:ext>
+            </a:extLst>
+          </p:cNvPr>
+          <p:cNvSpPr/>
+          <p:nvPr/>
+        </p:nvSpPr>
+        <p:spPr>
+          <a:xfrm xmlns:a="http://schemas.openxmlformats.org/drawingml/2006/main">
+            <a:off x="345486" y="2133920"/>
+            <a:ext cx="4093812" cy="2035744"/>
+          </a:xfrm>
+          <a:prstGeom xmlns:a="http://schemas.openxmlformats.org/drawingml/2006/main" prst="rect">
+            <a:avLst/>
+          </a:prstGeom>
+          <a:solidFill xmlns:a="http://schemas.openxmlformats.org/drawingml/2006/main">
+            <a:schemeClr val="bg1"/>
+          </a:solidFill>
+          <a:ln xmlns:a="http://schemas.openxmlformats.org/drawingml/2006/main">
+            <a:noFill/>
+          </a:ln>
+          <a:effectLst xmlns:a="http://schemas.openxmlformats.org/drawingml/2006/main">
+            <a:outerShdw blurRad="50800" dist="38100" dir="2700000" algn="tl" rotWithShape="0">
+              <a:prstClr val="black">
+                <a:alpha val="10000"/>
+              </a:prstClr>
+            </a:outerShdw>
+          </a:effectLst>
+        </p:spPr>
+        <p:style>
+          <a:lnRef xmlns:a="http://schemas.openxmlformats.org/drawingml/2006/main" idx="2">
+            <a:schemeClr val="accent1">
+              <a:shade val="15000"/>
+            </a:schemeClr>
+          </a:lnRef>
+          <a:fillRef xmlns:a="http://schemas.openxmlformats.org/drawingml/2006/main" idx="1">
+            <a:schemeClr val="accent1"/>
+          </a:fillRef>
+          <a:effectRef xmlns:a="http://schemas.openxmlformats.org/drawingml/2006/main" idx="0">
+            <a:schemeClr val="accent1"/>
+          </a:effectRef>
+          <a:fontRef xmlns:a="http://schemas.openxmlformats.org/drawingml/2006/main" idx="minor">
+            <a:schemeClr val="lt1"/>
+          </a:fontRef>
+        </p:style>
+        <p:txBody>
+          <a:bodyPr xmlns:a="http://schemas.openxmlformats.org/drawingml/2006/main" rtlCol="0" anchor="ctr"/>
+          <a:lstStyle xmlns:a="http://schemas.openxmlformats.org/drawingml/2006/main"/>
+          <a:p xmlns:a="http://schemas.openxmlformats.org/drawingml/2006/main">
+            <a:pPr algn="ctr"/>
+            <a:endParaRPr kumimoji="1" lang="zh-CN" altLang="en-US"/>
+          </a:p>
+        </p:txBody>
+      </p:sp>
+      <p:sp>
+        <p:nvSpPr>
+          <p:cNvPr id="10007" name="圆角矩形 24">
+            <a:extLst xmlns:a="http://schemas.openxmlformats.org/drawingml/2006/main">
+              <a:ext uri="{FF2B5EF4-FFF2-40B4-BE49-F238E27FC236}">
+                <a16:creationId xmlns:a16="http://schemas.microsoft.com/office/drawing/2014/main" id="{E397D437-4E52-D22D-6B27-72E8C793A13C}"/>
+              </a:ext>
+            </a:extLst>
+          </p:cNvPr>
+          <p:cNvSpPr/>
+          <p:nvPr/>
+        </p:nvSpPr>
+        <p:spPr>
+          <a:xfrm xmlns:a="http://schemas.openxmlformats.org/drawingml/2006/main">
+            <a:off x="345489" y="1076700"/>
+            <a:ext cx="2012699" cy="282437"/>
+          </a:xfrm>
+          <a:prstGeom xmlns:a="http://schemas.openxmlformats.org/drawingml/2006/main" prst="roundRect">
+            <a:avLst>
+              <a:gd name="adj" fmla="val 0"/>
+            </a:avLst>
+          </a:prstGeom>
+          <a:solidFill xmlns:a="http://schemas.openxmlformats.org/drawingml/2006/main">
+            <a:schemeClr val="tx2"/>
+          </a:solidFill>
+          <a:ln xmlns:a="http://schemas.openxmlformats.org/drawingml/2006/main" w="6350">
+            <a:noFill/>
+          </a:ln>
+        </p:spPr>
+        <p:style>
+          <a:lnRef xmlns:a="http://schemas.openxmlformats.org/drawingml/2006/main" idx="2">
+            <a:schemeClr val="accent1">
+              <a:shade val="15000"/>
+            </a:schemeClr>
+          </a:lnRef>
+          <a:fillRef xmlns:a="http://schemas.openxmlformats.org/drawingml/2006/main" idx="1">
+            <a:schemeClr val="accent1"/>
+          </a:fillRef>
+          <a:effectRef xmlns:a="http://schemas.openxmlformats.org/drawingml/2006/main" idx="0">
+            <a:schemeClr val="accent1"/>
+          </a:effectRef>
+          <a:fontRef xmlns:a="http://schemas.openxmlformats.org/drawingml/2006/main" idx="minor">
+            <a:schemeClr val="lt1"/>
+          </a:fontRef>
+        </p:style>
+        <p:txBody>
+          <a:bodyPr xmlns:a="http://schemas.openxmlformats.org/drawingml/2006/main" rtlCol="0" anchor="ctr"/>
+          <a:lstStyle xmlns:a="http://schemas.openxmlformats.org/drawingml/2006/main"/>
+          <a:p xmlns:a="http://schemas.openxmlformats.org/drawingml/2006/main">
+            <a:pPr algn="ctr"/>
+            <a:r>
+              <a:rPr kumimoji="1" lang="en-US" altLang="zh-CN" sz="1600" b="1" dirty="0"/>
+              <a:t>Optimizing Returns</a:t>
+            </a:r>
+            <a:endParaRPr kumimoji="1" lang="zh-CN" altLang="en-US" sz="1600" b="1" dirty="0"/>
+          </a:p>
+        </p:txBody>
+      </p:sp>
+      <p:sp>
+        <p:nvSpPr>
+          <p:cNvPr id="10008" name="矩形 27">
+            <a:extLst xmlns:a="http://schemas.openxmlformats.org/drawingml/2006/main">
+              <a:ext uri="{FF2B5EF4-FFF2-40B4-BE49-F238E27FC236}">
+                <a16:creationId xmlns:a16="http://schemas.microsoft.com/office/drawing/2014/main" id="{79E0164F-8AEF-E13C-5944-82136D1891B0}"/>
+              </a:ext>
+            </a:extLst>
+          </p:cNvPr>
+          <p:cNvSpPr/>
+          <p:nvPr/>
+        </p:nvSpPr>
+        <p:spPr>
+          <a:xfrm xmlns:a="http://schemas.openxmlformats.org/drawingml/2006/main">
+            <a:off x="345488" y="1356860"/>
+            <a:ext cx="11501023" cy="612535"/>
+          </a:xfrm>
+          <a:prstGeom xmlns:a="http://schemas.openxmlformats.org/drawingml/2006/main" prst="rect">
+            <a:avLst/>
+          </a:prstGeom>
+          <a:solidFill xmlns:a="http://schemas.openxmlformats.org/drawingml/2006/main">
+            <a:schemeClr val="bg2"/>
+          </a:solidFill>
+          <a:ln xmlns:a="http://schemas.openxmlformats.org/drawingml/2006/main">
+            <a:noFill/>
+          </a:ln>
+        </p:spPr>
+        <p:style>
+          <a:lnRef xmlns:a="http://schemas.openxmlformats.org/drawingml/2006/main" idx="2">
+            <a:schemeClr val="accent1">
+              <a:shade val="15000"/>
+            </a:schemeClr>
+          </a:lnRef>
+          <a:fillRef xmlns:a="http://schemas.openxmlformats.org/drawingml/2006/main" idx="1">
+            <a:schemeClr val="accent1"/>
+          </a:fillRef>
+          <a:effectRef xmlns:a="http://schemas.openxmlformats.org/drawingml/2006/main" idx="0">
+            <a:schemeClr val="accent1"/>
+          </a:effectRef>
+          <a:fontRef xmlns:a="http://schemas.openxmlformats.org/drawingml/2006/main" idx="minor">
+            <a:schemeClr val="lt1"/>
+          </a:fontRef>
+        </p:style>
+        <p:txBody>
+          <a:bodyPr xmlns:a="http://schemas.openxmlformats.org/drawingml/2006/main" rtlCol="0" anchor="ctr"/>
+          <a:lstStyle xmlns:a="http://schemas.openxmlformats.org/drawingml/2006/main"/>
+          <a:p xmlns:a="http://schemas.openxmlformats.org/drawingml/2006/main">
+            <a:pPr algn="just"/>
+            <a:r>
+              <a:rPr kumimoji="1" lang="en-US" altLang="zh-CN" sz="1400" dirty="0">
+                <a:solidFill>
+                  <a:schemeClr val="tx1"/>
+                </a:solidFill>
+              </a:rPr>
+              <a:t>Retrofit merchant projects to stabilize cash flows while expanding EE’s global BESS network in high-return markets. Convert German standalone tolling projects to boost equity growth. Optimized portfolio equity allocations were achieved using </a:t>
+            </a:r>
+            <a:r>
+              <a:rPr kumimoji="1" lang="en-US" altLang="zh-CN" sz="1400" b="1" dirty="0">
+                <a:solidFill>
+                  <a:schemeClr val="tx1"/>
+                </a:solidFill>
+              </a:rPr>
+              <a:t>Mixed-Integer Linear Programming.</a:t>
+            </a:r>
+          </a:p>
+        </p:txBody>
+      </p:sp>
+      <p:sp>
+        <p:nvSpPr>
+          <p:cNvPr id="10009" name="圆角矩形 61">
+            <a:extLst xmlns:a="http://schemas.openxmlformats.org/drawingml/2006/main">
+              <a:ext uri="{FF2B5EF4-FFF2-40B4-BE49-F238E27FC236}">
+                <a16:creationId xmlns:a16="http://schemas.microsoft.com/office/drawing/2014/main" id="{E69AE45E-1DE2-4DAB-7FF4-44303F245327}"/>
+              </a:ext>
+            </a:extLst>
+          </p:cNvPr>
+          <p:cNvSpPr/>
+          <p:nvPr/>
+        </p:nvSpPr>
+        <p:spPr>
+          <a:xfrm xmlns:a="http://schemas.openxmlformats.org/drawingml/2006/main">
+            <a:off x="345485" y="4332458"/>
+            <a:ext cx="4093811" cy="282437"/>
+          </a:xfrm>
+          <a:prstGeom xmlns:a="http://schemas.openxmlformats.org/drawingml/2006/main" prst="roundRect">
+            <a:avLst>
+              <a:gd name="adj" fmla="val 0"/>
+            </a:avLst>
+          </a:prstGeom>
+          <a:solidFill xmlns:a="http://schemas.openxmlformats.org/drawingml/2006/main">
+            <a:schemeClr val="bg2"/>
+          </a:solidFill>
+          <a:ln xmlns:a="http://schemas.openxmlformats.org/drawingml/2006/main" w="19050">
+            <a:solidFill>
+              <a:schemeClr val="bg2"/>
+            </a:solidFill>
+          </a:ln>
+        </p:spPr>
+        <p:style>
+          <a:lnRef xmlns:a="http://schemas.openxmlformats.org/drawingml/2006/main" idx="2">
+            <a:schemeClr val="accent1">
+              <a:shade val="15000"/>
+            </a:schemeClr>
+          </a:lnRef>
+          <a:fillRef xmlns:a="http://schemas.openxmlformats.org/drawingml/2006/main" idx="1">
+            <a:schemeClr val="accent1"/>
+          </a:fillRef>
+          <a:effectRef xmlns:a="http://schemas.openxmlformats.org/drawingml/2006/main" idx="0">
+            <a:schemeClr val="accent1"/>
+          </a:effectRef>
+          <a:fontRef xmlns:a="http://schemas.openxmlformats.org/drawingml/2006/main" idx="minor">
+            <a:schemeClr val="lt1"/>
+          </a:fontRef>
+        </p:style>
+        <p:txBody>
+          <a:bodyPr xmlns:a="http://schemas.openxmlformats.org/drawingml/2006/main" rtlCol="0" anchor="ctr"/>
+          <a:lstStyle xmlns:a="http://schemas.openxmlformats.org/drawingml/2006/main"/>
+          <a:p xmlns:a="http://schemas.openxmlformats.org/drawingml/2006/main">
+            <a:pPr algn="ctr"/>
+            <a:r>
+              <a:rPr kumimoji="1" lang="en-US" altLang="zh-CN" sz="1600" b="1" dirty="0">
+                <a:solidFill>
+                  <a:schemeClr val="tx2"/>
+                </a:solidFill>
+              </a:rPr>
+              <a:t>Key Priorities</a:t>
+            </a:r>
+            <a:endParaRPr kumimoji="1" lang="zh-CN" altLang="en-US" sz="1600" b="1" dirty="0">
+              <a:solidFill>
+                <a:schemeClr val="tx2"/>
+              </a:solidFill>
+            </a:endParaRPr>
+          </a:p>
+        </p:txBody>
+      </p:sp>
+      <p:sp>
+        <p:nvSpPr>
+          <p:cNvPr id="10010" name="矩形 84">
+            <a:extLst xmlns:a="http://schemas.openxmlformats.org/drawingml/2006/main">
+              <a:ext uri="{FF2B5EF4-FFF2-40B4-BE49-F238E27FC236}">
+                <a16:creationId xmlns:a16="http://schemas.microsoft.com/office/drawing/2014/main" id="{746FE38C-0400-C837-CAC2-BBFE1F7867E4}"/>
+              </a:ext>
+            </a:extLst>
+          </p:cNvPr>
+          <p:cNvSpPr/>
+          <p:nvPr/>
+        </p:nvSpPr>
+        <p:spPr>
+          <a:xfrm xmlns:a="http://schemas.openxmlformats.org/drawingml/2006/main">
+            <a:off x="5137950" y="4993701"/>
+            <a:ext cx="6708559" cy="885478"/>
+          </a:xfrm>
+          <a:prstGeom xmlns:a="http://schemas.openxmlformats.org/drawingml/2006/main" prst="rect">
+            <a:avLst/>
+          </a:prstGeom>
+          <a:solidFill xmlns:a="http://schemas.openxmlformats.org/drawingml/2006/main">
+            <a:schemeClr val="bg2"/>
+          </a:solidFill>
+          <a:ln xmlns:a="http://schemas.openxmlformats.org/drawingml/2006/main">
+            <a:noFill/>
+          </a:ln>
+        </p:spPr>
+        <p:style>
+          <a:lnRef xmlns:a="http://schemas.openxmlformats.org/drawingml/2006/main" idx="2">
+            <a:schemeClr val="accent1">
+              <a:shade val="15000"/>
+            </a:schemeClr>
+          </a:lnRef>
+          <a:fillRef xmlns:a="http://schemas.openxmlformats.org/drawingml/2006/main" idx="1">
+            <a:schemeClr val="accent1"/>
+          </a:fillRef>
+          <a:effectRef xmlns:a="http://schemas.openxmlformats.org/drawingml/2006/main" idx="0">
+            <a:schemeClr val="accent1"/>
+          </a:effectRef>
+          <a:fontRef xmlns:a="http://schemas.openxmlformats.org/drawingml/2006/main" idx="minor">
+            <a:schemeClr val="lt1"/>
+          </a:fontRef>
+        </p:style>
+        <p:txBody>
+          <a:bodyPr xmlns:a="http://schemas.openxmlformats.org/drawingml/2006/main" rtlCol="0" anchor="ctr"/>
+          <a:lstStyle xmlns:a="http://schemas.openxmlformats.org/drawingml/2006/main"/>
+          <a:p xmlns:a="http://schemas.openxmlformats.org/drawingml/2006/main">
+            <a:pPr algn="just"/>
+            <a:r>
+              <a:rPr kumimoji="1" lang="en-US" altLang="zh-CN" sz="1400" b="1" dirty="0">
+                <a:solidFill>
+                  <a:schemeClr val="tx1"/>
+                </a:solidFill>
+              </a:rPr>
+              <a:t>Genki Forest is suggested to raise ex-factory price by CN¥0.25–0.30 per bottle</a:t>
+            </a:r>
+          </a:p>
+          <a:p xmlns:a="http://schemas.openxmlformats.org/drawingml/2006/main">
+            <a:pPr marL="285750" indent="-285750" algn="just">
+              <a:buFont typeface="Arial" panose="020B0604020202020204" pitchFamily="34" charset="0"/>
+              <a:buChar char="•"/>
+            </a:pPr>
+            <a:r>
+              <a:rPr kumimoji="1" lang="en-US" altLang="zh-CN" sz="1400" dirty="0">
+                <a:solidFill>
+                  <a:schemeClr val="tx1"/>
+                </a:solidFill>
+              </a:rPr>
+              <a:t>Terminal price could raise CN¥0.30–0.50 per bottle</a:t>
+            </a:r>
+          </a:p>
+          <a:p xmlns:a="http://schemas.openxmlformats.org/drawingml/2006/main">
+            <a:pPr marL="285750" indent="-285750" algn="just">
+              <a:buFont typeface="Arial" panose="020B0604020202020204" pitchFamily="34" charset="0"/>
+              <a:buChar char="•"/>
+            </a:pPr>
+            <a:r>
+              <a:rPr kumimoji="1" lang="en-US" altLang="zh-CN" sz="1400" dirty="0">
+                <a:solidFill>
+                  <a:schemeClr val="tx1"/>
+                </a:solidFill>
+              </a:rPr>
+              <a:t>Potential risk and mitigation exist in implementation</a:t>
+            </a:r>
+          </a:p>
+        </p:txBody>
+      </p:sp>
+      <p:sp>
+        <p:nvSpPr>
+          <p:cNvPr id="10011" name="矩形 92">
+            <a:extLst xmlns:a="http://schemas.openxmlformats.org/drawingml/2006/main">
+              <a:ext uri="{FF2B5EF4-FFF2-40B4-BE49-F238E27FC236}">
+                <a16:creationId xmlns:a16="http://schemas.microsoft.com/office/drawing/2014/main" id="{EFCC0494-57AE-3F1D-B961-E866DE11BFD4}"/>
+              </a:ext>
+            </a:extLst>
+          </p:cNvPr>
+          <p:cNvSpPr/>
+          <p:nvPr/>
+        </p:nvSpPr>
+        <p:spPr>
+          <a:xfrm xmlns:a="http://schemas.openxmlformats.org/drawingml/2006/main">
+            <a:off x="345486" y="2472474"/>
+            <a:ext cx="4093812" cy="1694464"/>
+          </a:xfrm>
+          <a:prstGeom xmlns:a="http://schemas.openxmlformats.org/drawingml/2006/main" prst="rect">
+            <a:avLst/>
+          </a:prstGeom>
+          <a:noFill xmlns:a="http://schemas.openxmlformats.org/drawingml/2006/main"/>
+          <a:ln xmlns:a="http://schemas.openxmlformats.org/drawingml/2006/main">
+            <a:noFill/>
+          </a:ln>
+        </p:spPr>
+        <p:style>
+          <a:lnRef xmlns:a="http://schemas.openxmlformats.org/drawingml/2006/main" idx="2">
+            <a:schemeClr val="accent1">
+              <a:shade val="15000"/>
+            </a:schemeClr>
+          </a:lnRef>
+          <a:fillRef xmlns:a="http://schemas.openxmlformats.org/drawingml/2006/main" idx="1">
+            <a:schemeClr val="accent1"/>
+          </a:fillRef>
+          <a:effectRef xmlns:a="http://schemas.openxmlformats.org/drawingml/2006/main" idx="0">
+            <a:schemeClr val="accent1"/>
+          </a:effectRef>
+          <a:fontRef xmlns:a="http://schemas.openxmlformats.org/drawingml/2006/main" idx="minor">
+            <a:schemeClr val="lt1"/>
+          </a:fontRef>
+        </p:style>
+        <p:txBody>
+          <a:bodyPr xmlns:a="http://schemas.openxmlformats.org/drawingml/2006/main" rtlCol="0" anchor="t"/>
+          <a:lstStyle xmlns:a="http://schemas.openxmlformats.org/drawingml/2006/main"/>
+          <a:p xmlns:a="http://schemas.openxmlformats.org/drawingml/2006/main">
+            <a:pPr>
+              <a:lnSpc>
+                <a:spcPct val="150000"/>
+              </a:lnSpc>
+            </a:pPr>
+            <a:r>
+              <a:rPr kumimoji="1" lang="en-US" altLang="zh-CN" sz="1400" b="1" dirty="0">
+                <a:solidFill>
+                  <a:schemeClr val="tx1"/>
+                </a:solidFill>
+              </a:rPr>
+              <a:t>Long-Term Value Creation</a:t>
+            </a:r>
+          </a:p>
+          <a:p xmlns:a="http://schemas.openxmlformats.org/drawingml/2006/main">
+            <a:pPr marL="285750" indent="-285750">
+              <a:buFont typeface="Arial" panose="020B0604020202020204" pitchFamily="34" charset="0"/>
+              <a:buChar char="•"/>
+            </a:pPr>
+            <a:r>
+              <a:rPr kumimoji="1" lang="en-US" altLang="zh-CN" sz="1400" dirty="0">
+                <a:solidFill>
+                  <a:schemeClr val="tx1"/>
+                </a:solidFill>
+              </a:rPr>
+              <a:t>Close the value gap between high-output and low-revenue markets through full-chain control</a:t>
+            </a:r>
+            <a:endParaRPr kumimoji="1" lang="en-US" altLang="zh-CN" sz="1400" b="1" dirty="0">
+              <a:solidFill>
+                <a:schemeClr val="tx1"/>
+              </a:solidFill>
+            </a:endParaRPr>
+          </a:p>
+          <a:p xmlns:a="http://schemas.openxmlformats.org/drawingml/2006/main">
+            <a:pPr>
+              <a:lnSpc>
+                <a:spcPct val="150000"/>
+              </a:lnSpc>
+            </a:pPr>
+            <a:r>
+              <a:rPr kumimoji="1" lang="en-US" altLang="zh-CN" sz="1400" b="1" dirty="0">
+                <a:solidFill>
+                  <a:schemeClr val="tx1"/>
+                </a:solidFill>
+              </a:rPr>
+              <a:t>Capital Recycling</a:t>
+            </a:r>
+          </a:p>
+          <a:p xmlns:a="http://schemas.openxmlformats.org/drawingml/2006/main">
+            <a:pPr marL="285750" indent="-285750">
+              <a:buFont typeface="Arial" panose="020B0604020202020204" pitchFamily="34" charset="0"/>
+              <a:buChar char="•"/>
+            </a:pPr>
+            <a:r>
+              <a:rPr kumimoji="1" lang="en-US" altLang="zh-CN" sz="1400" dirty="0">
+                <a:solidFill>
+                  <a:schemeClr val="tx1"/>
+                </a:solidFill>
+              </a:rPr>
+              <a:t>Anchor BESS growth in high-capability markets for reliable expansion</a:t>
+            </a:r>
+            <a:endParaRPr kumimoji="1" lang="en-US" altLang="zh-CN" sz="1400" b="1" dirty="0">
+              <a:solidFill>
+                <a:schemeClr val="tx1"/>
+              </a:solidFill>
+            </a:endParaRPr>
+          </a:p>
+        </p:txBody>
+      </p:sp>
+      <p:sp>
+        <p:nvSpPr>
+          <p:cNvPr id="10012" name="圆角矩形 76">
+            <a:extLst xmlns:a="http://schemas.openxmlformats.org/drawingml/2006/main">
+              <a:ext uri="{FF2B5EF4-FFF2-40B4-BE49-F238E27FC236}">
+                <a16:creationId xmlns:a16="http://schemas.microsoft.com/office/drawing/2014/main" id="{BFAE422C-1765-50D1-BEB2-2C81DA15E6BC}"/>
+              </a:ext>
+            </a:extLst>
+          </p:cNvPr>
+          <p:cNvSpPr/>
+          <p:nvPr/>
+        </p:nvSpPr>
+        <p:spPr>
+          <a:xfrm xmlns:a="http://schemas.openxmlformats.org/drawingml/2006/main">
+            <a:off x="345486" y="2161979"/>
+            <a:ext cx="261417" cy="282437"/>
+          </a:xfrm>
+          <a:prstGeom xmlns:a="http://schemas.openxmlformats.org/drawingml/2006/main" prst="roundRect">
+            <a:avLst>
+              <a:gd name="adj" fmla="val 0"/>
+            </a:avLst>
+          </a:prstGeom>
+          <a:solidFill xmlns:a="http://schemas.openxmlformats.org/drawingml/2006/main">
+            <a:schemeClr val="tx2"/>
+          </a:solidFill>
+          <a:ln xmlns:a="http://schemas.openxmlformats.org/drawingml/2006/main" w="6350">
+            <a:noFill/>
+          </a:ln>
+        </p:spPr>
+        <p:style>
+          <a:lnRef xmlns:a="http://schemas.openxmlformats.org/drawingml/2006/main" idx="2">
+            <a:schemeClr val="accent1">
+              <a:shade val="15000"/>
+            </a:schemeClr>
+          </a:lnRef>
+          <a:fillRef xmlns:a="http://schemas.openxmlformats.org/drawingml/2006/main" idx="1">
+            <a:schemeClr val="accent1"/>
+          </a:fillRef>
+          <a:effectRef xmlns:a="http://schemas.openxmlformats.org/drawingml/2006/main" idx="0">
+            <a:schemeClr val="accent1"/>
+          </a:effectRef>
+          <a:fontRef xmlns:a="http://schemas.openxmlformats.org/drawingml/2006/main" idx="minor">
+            <a:schemeClr val="lt1"/>
+          </a:fontRef>
+        </p:style>
+        <p:txBody>
+          <a:bodyPr xmlns:a="http://schemas.openxmlformats.org/drawingml/2006/main" rtlCol="0" anchor="ctr"/>
+          <a:lstStyle xmlns:a="http://schemas.openxmlformats.org/drawingml/2006/main"/>
+          <a:p xmlns:a="http://schemas.openxmlformats.org/drawingml/2006/main">
+            <a:pPr algn="ctr"/>
+            <a:r>
+              <a:rPr kumimoji="1" lang="en-US" altLang="zh-CN" sz="1600" b="1" dirty="0"/>
+              <a:t>1</a:t>
+            </a:r>
+            <a:endParaRPr kumimoji="1" lang="zh-CN" altLang="en-US" sz="1600" b="1" dirty="0"/>
+          </a:p>
+        </p:txBody>
+      </p:sp>
+      <p:sp>
+        <p:nvSpPr>
+          <p:cNvPr id="10013" name="圆角矩形 86">
+            <a:extLst xmlns:a="http://schemas.openxmlformats.org/drawingml/2006/main">
+              <a:ext uri="{FF2B5EF4-FFF2-40B4-BE49-F238E27FC236}">
+                <a16:creationId xmlns:a16="http://schemas.microsoft.com/office/drawing/2014/main" id="{60904E53-D94C-507F-8CAF-55E868BA4139}"/>
+              </a:ext>
+            </a:extLst>
+          </p:cNvPr>
+          <p:cNvSpPr/>
+          <p:nvPr/>
+        </p:nvSpPr>
+        <p:spPr>
+          <a:xfrm xmlns:a="http://schemas.openxmlformats.org/drawingml/2006/main">
+            <a:off x="5139910" y="4473676"/>
+            <a:ext cx="261417" cy="282437"/>
+          </a:xfrm>
+          <a:prstGeom xmlns:a="http://schemas.openxmlformats.org/drawingml/2006/main" prst="roundRect">
+            <a:avLst>
+              <a:gd name="adj" fmla="val 0"/>
+            </a:avLst>
+          </a:prstGeom>
+          <a:solidFill xmlns:a="http://schemas.openxmlformats.org/drawingml/2006/main">
+            <a:schemeClr val="tx2"/>
+          </a:solidFill>
+          <a:ln xmlns:a="http://schemas.openxmlformats.org/drawingml/2006/main" w="6350">
+            <a:noFill/>
+          </a:ln>
+        </p:spPr>
+        <p:style>
+          <a:lnRef xmlns:a="http://schemas.openxmlformats.org/drawingml/2006/main" idx="2">
+            <a:schemeClr val="accent1">
+              <a:shade val="15000"/>
+            </a:schemeClr>
+          </a:lnRef>
+          <a:fillRef xmlns:a="http://schemas.openxmlformats.org/drawingml/2006/main" idx="1">
+            <a:schemeClr val="accent1"/>
+          </a:fillRef>
+          <a:effectRef xmlns:a="http://schemas.openxmlformats.org/drawingml/2006/main" idx="0">
+            <a:schemeClr val="accent1"/>
+          </a:effectRef>
+          <a:fontRef xmlns:a="http://schemas.openxmlformats.org/drawingml/2006/main" idx="minor">
+            <a:schemeClr val="lt1"/>
+          </a:fontRef>
+        </p:style>
+        <p:txBody>
+          <a:bodyPr xmlns:a="http://schemas.openxmlformats.org/drawingml/2006/main" rtlCol="0" anchor="ctr"/>
+          <a:lstStyle xmlns:a="http://schemas.openxmlformats.org/drawingml/2006/main"/>
+          <a:p xmlns:a="http://schemas.openxmlformats.org/drawingml/2006/main">
+            <a:pPr algn="ctr"/>
+            <a:r>
+              <a:rPr kumimoji="1" lang="en-US" altLang="zh-CN" sz="1600" b="1" dirty="0"/>
+              <a:t>3</a:t>
+            </a:r>
+            <a:endParaRPr kumimoji="1" lang="zh-CN" altLang="en-US" sz="1600" b="1" dirty="0"/>
+          </a:p>
+        </p:txBody>
+      </p:sp>
+    </p:spTree>
+  </p:cSld>
+</p:sld>
+</file>
+
 <file path=ppt/theme/theme1.xml><?xml version="1.0" encoding="utf-8"?>
-<a:theme xmlns:a="http://schemas.openxmlformats.org/drawingml/2006/main" name="Office 主题​​">
+<a:theme xmlns:thm15="http://schemas.microsoft.com/office/thememl/2012/main" xmlns:a="http://schemas.openxmlformats.org/drawingml/2006/main" name="Office 主题​​">
   <a:themeElements>
     <a:clrScheme name="自定义 7">
       <a:dk1>

</xml_diff>

<commit_message>
chore: remove obsolete worktree and update Design Draft PowerPoint presentation
</commit_message>
<xml_diff>
--- a/Drafts/Design Draft.pptx
+++ b/Drafts/Design Draft.pptx
@@ -5196,7 +5196,7 @@
             </p:custDataLst>
             <p:extLst>
               <p:ext uri="{D42A27DB-BD31-4B8C-83A1-F6EECF244321}">
-                <p14:modId xmlns:p14="http://schemas.microsoft.com/office/powerpoint/2010/main" val="3469274445"/>
+                <p14:modId xmlns:p14="http://schemas.microsoft.com/office/powerpoint/2010/main" val="3977461652"/>
               </p:ext>
             </p:extLst>
           </p:nvPr>
@@ -40261,6 +40261,9 @@
   <wetp:taskpane dockstate="right" visibility="0" width="350" row="0">
     <wetp:webextensionref xmlns:r="http://schemas.openxmlformats.org/officeDocument/2006/relationships" r:id="rId2"/>
   </wetp:taskpane>
+  <wetp:taskpane dockstate="right" visibility="0" width="350" row="0">
+    <wetp:webextensionref xmlns:r="http://schemas.openxmlformats.org/officeDocument/2006/relationships" r:id="rId3"/>
+  </wetp:taskpane>
 </wetp:taskpanes>
 </file>
 
@@ -40286,4 +40289,18 @@
   <we:bindings/>
   <we:snapshot xmlns:r="http://schemas.openxmlformats.org/officeDocument/2006/relationships"/>
 </we:webextension>
+</file>
+
+<file path=ppt/webextensions/webextension3.xml><?xml version="1.0" encoding="utf-8"?>
+<we:webextension xmlns:we="http://schemas.microsoft.com/office/webextensions/webextension/2010/11" id="{D6383224-8183-6F42-9D6D-ECE34A7F4D6C}">
+  <we:reference id="wa200010001" version="1.0.0.1" store="en-US" storeType="OMEX"/>
+  <we:alternateReferences>
+    <we:reference id="wa200010001" version="1.0.0.1" store="en-US" storeType="OMEX"/>
+  </we:alternateReferences>
+  <we:properties>
+    <we:property name="claude.fileId" value="&quot;290d22f7-937f-47f2-aaae-481a155bf563&quot;"/>
+  </we:properties>
+  <we:bindings/>
+  <we:snapshot xmlns:r="http://schemas.openxmlformats.org/officeDocument/2006/relationships"/>
+</we:webextension>
 </file>
</xml_diff>